<commit_message>
detalha laboratório Docker da Aula 2 e remove polyfill externo
</commit_message>
<xml_diff>
--- a/slides/A02-ativos-ameacas-e-vulnerabilidades/fonte/A02-ativos-ameacas-e-vulnerabilidades.pptx
+++ b/slides/A02-ativos-ameacas-e-vulnerabilidades/fonte/A02-ativos-ameacas-e-vulnerabilidades.pptx
@@ -1126,7 +1126,7 @@
           <a:p>
             <a:r>
               <a:rPr lang="en-US" dirty="0"/>
-              <a:t>Distribua o PDF e troque os papéis após a evidência inicial.</a:t>
+              <a:t>Confirme Docker ativo e URL 127.0.0.1. O PDF contém Windows/Linux, diagnóstico de porta, logs e limpeza.</a:t>
             </a:r>
             <a:endParaRPr lang="en-US" dirty="0"/>
           </a:p>
@@ -6391,7 +6391,7 @@
                   <a:srgbClr val="12304A"/>
                 </a:solidFill>
               </a:rPr>
-              <a:t>Produza um ticket que outra equipe possa retestar</a:t>
+              <a:t>Suba localmente, investigue e encerre com segurança</a:t>
             </a:r>
             <a:endParaRPr lang="en-US" sz="3000" dirty="0"/>
           </a:p>
@@ -6429,7 +6429,7 @@
                   <a:srgbClr val="4B5E71"/>
                 </a:solidFill>
               </a:rPr>
-              <a:t>A flag não é o produto da atividade.</a:t>
+              <a:t>Cada estudante acessa seu próprio container em http://127.0.0.1:3000.</a:t>
             </a:r>
             <a:endParaRPr lang="en-US" sz="1700" dirty="0"/>
           </a:p>
@@ -6443,8 +6443,8 @@
         </p:nvSpPr>
         <p:spPr>
           <a:xfrm>
-            <a:off x="731520" y="2011680"/>
-            <a:ext cx="6903720" cy="3337560"/>
+            <a:off x="594360" y="1965960"/>
+            <a:ext cx="7178040" cy="3520440"/>
           </a:xfrm>
           <a:prstGeom prst="roundRect">
             <a:avLst/>
@@ -6468,8 +6468,8 @@
         </p:nvSpPr>
         <p:spPr>
           <a:xfrm>
-            <a:off x="1097280" y="2423160"/>
-            <a:ext cx="1828800" cy="274320"/>
+            <a:off x="932688" y="2286000"/>
+            <a:ext cx="6217920" cy="274320"/>
           </a:xfrm>
           <a:prstGeom prst="rect">
             <a:avLst/>
@@ -6485,14 +6485,14 @@
               <a:buNone/>
             </a:pPr>
             <a:r>
-              <a:rPr lang="en-US" sz="1500" b="1" dirty="0">
+              <a:rPr lang="en-US" sz="1300" b="1" dirty="0">
                 <a:solidFill>
                   <a:srgbClr val="087F7A"/>
                 </a:solidFill>
               </a:rPr>
-              <a:t>MISSÃO</a:t>
-            </a:r>
-            <a:endParaRPr lang="en-US" sz="1500" dirty="0"/>
+              <a:t>PREPARAÇÃO — POWERSHELL OU TERMINAL LINUX</a:t>
+            </a:r>
+            <a:endParaRPr lang="en-US" sz="1300" dirty="0"/>
           </a:p>
         </p:txBody>
       </p:sp>
@@ -6504,8 +6504,8 @@
         </p:nvSpPr>
         <p:spPr>
           <a:xfrm>
-            <a:off x="1097280" y="2971800"/>
-            <a:ext cx="5760720" cy="1371600"/>
+            <a:off x="932688" y="2761488"/>
+            <a:ext cx="6217920" cy="1143000"/>
           </a:xfrm>
           <a:prstGeom prst="rect">
             <a:avLst/>
@@ -6523,14 +6523,34 @@
               <a:buNone/>
             </a:pPr>
             <a:r>
-              <a:rPr lang="en-US" sz="2500" b="1" dirty="0">
+              <a:rPr lang="en-US" sz="1550" dirty="0">
                 <a:solidFill>
                   <a:srgbClr val="12304A"/>
                 </a:solidFill>
-              </a:rPr>
-              <a:t>Relacione ativo, fraqueza, vetor e impacto; escolha um controle e prove como validá-lo.</a:t>
-            </a:r>
-            <a:endParaRPr lang="en-US" sz="2500" dirty="0"/>
+                <a:latin typeface="Courier New" pitchFamily="34" charset="0"/>
+                <a:ea typeface="Courier New" pitchFamily="34" charset="-122"/>
+                <a:cs typeface="Courier New" pitchFamily="34" charset="-120"/>
+              </a:rPr>
+              <a:t>docker pull bkimminich/juice-shop</a:t>
+            </a:r>
+            <a:endParaRPr lang="en-US" sz="1550" dirty="0"/>
+          </a:p>
+          <a:p>
+            <a:pPr indent="0" marL="0">
+              <a:buNone/>
+            </a:pPr>
+            <a:r>
+              <a:rPr lang="en-US" sz="1550" dirty="0">
+                <a:solidFill>
+                  <a:srgbClr val="12304A"/>
+                </a:solidFill>
+                <a:latin typeface="Courier New" pitchFamily="34" charset="0"/>
+                <a:ea typeface="Courier New" pitchFamily="34" charset="-122"/>
+                <a:cs typeface="Courier New" pitchFamily="34" charset="-120"/>
+              </a:rPr>
+              <a:t>docker run --rm -d --name juice-shop-a02 -p 127.0.0.1:3000:3000 bkimminich/juice-shop</a:t>
+            </a:r>
+            <a:endParaRPr lang="en-US" sz="1550" dirty="0"/>
           </a:p>
         </p:txBody>
       </p:sp>
@@ -6542,7 +6562,79 @@
         </p:nvSpPr>
         <p:spPr>
           <a:xfrm>
-            <a:off x="8321040" y="2331720"/>
+            <a:off x="932688" y="4261104"/>
+            <a:ext cx="6035040" cy="384048"/>
+          </a:xfrm>
+          <a:prstGeom prst="rect">
+            <a:avLst/>
+          </a:prstGeom>
+          <a:noFill/>
+          <a:ln/>
+        </p:spPr>
+        <p:txBody>
+          <a:bodyPr wrap="square" lIns="0" tIns="0" rIns="0" bIns="0" rtlCol="0" anchor="ctr"/>
+          <a:lstStyle/>
+          <a:p>
+            <a:pPr indent="0" marL="0">
+              <a:buNone/>
+            </a:pPr>
+            <a:r>
+              <a:rPr lang="en-US" sz="1900" b="1" dirty="0">
+                <a:solidFill>
+                  <a:srgbClr val="0B65C2"/>
+                </a:solidFill>
+              </a:rPr>
+              <a:t>ABRA  http://127.0.0.1:3000</a:t>
+            </a:r>
+            <a:endParaRPr lang="en-US" sz="1900" dirty="0"/>
+          </a:p>
+        </p:txBody>
+      </p:sp>
+      <p:sp>
+        <p:nvSpPr>
+          <p:cNvPr id="9" name="Text 7"/>
+          <p:cNvSpPr/>
+          <p:nvPr/>
+        </p:nvSpPr>
+        <p:spPr>
+          <a:xfrm>
+            <a:off x="932688" y="4846320"/>
+            <a:ext cx="6035040" cy="310896"/>
+          </a:xfrm>
+          <a:prstGeom prst="rect">
+            <a:avLst/>
+          </a:prstGeom>
+          <a:noFill/>
+          <a:ln/>
+        </p:spPr>
+        <p:txBody>
+          <a:bodyPr wrap="square" lIns="0" tIns="0" rIns="0" bIns="0" rtlCol="0" anchor="ctr"/>
+          <a:lstStyle/>
+          <a:p>
+            <a:pPr indent="0" marL="0">
+              <a:buNone/>
+            </a:pPr>
+            <a:r>
+              <a:rPr lang="en-US" sz="1500" b="1" dirty="0">
+                <a:solidFill>
+                  <a:srgbClr val="B42318"/>
+                </a:solidFill>
+              </a:rPr>
+              <a:t>ENCERRE  docker stop juice-shop-a02</a:t>
+            </a:r>
+            <a:endParaRPr lang="en-US" sz="1500" dirty="0"/>
+          </a:p>
+        </p:txBody>
+      </p:sp>
+      <p:sp>
+        <p:nvSpPr>
+          <p:cNvPr id="10" name="Text 8"/>
+          <p:cNvSpPr/>
+          <p:nvPr/>
+        </p:nvSpPr>
+        <p:spPr>
+          <a:xfrm>
+            <a:off x="8275320" y="2240280"/>
             <a:ext cx="2377440" cy="274320"/>
           </a:xfrm>
           <a:prstGeom prst="rect">
@@ -6572,14 +6664,14 @@
       </p:sp>
       <p:sp>
         <p:nvSpPr>
-          <p:cNvPr id="9" name="Text 7"/>
-          <p:cNvSpPr/>
-          <p:nvPr/>
-        </p:nvSpPr>
-        <p:spPr>
-          <a:xfrm>
-            <a:off x="8321040" y="2834640"/>
-            <a:ext cx="2834640" cy="1600200"/>
+          <p:cNvPr id="11" name="Text 9"/>
+          <p:cNvSpPr/>
+          <p:nvPr/>
+        </p:nvSpPr>
+        <p:spPr>
+          <a:xfrm>
+            <a:off x="8275320" y="2761488"/>
+            <a:ext cx="2926080" cy="1600200"/>
           </a:xfrm>
           <a:prstGeom prst="rect">
             <a:avLst/>
@@ -6595,69 +6687,69 @@
               <a:buNone/>
             </a:pPr>
             <a:r>
-              <a:rPr lang="en-US" sz="1900" b="1" dirty="0">
+              <a:rPr lang="en-US" sz="1850" b="1" dirty="0">
                 <a:solidFill>
                   <a:srgbClr val="12304A"/>
                 </a:solidFill>
               </a:rPr>
-              <a:t>Inventário priorizado</a:t>
-            </a:r>
-            <a:endParaRPr lang="en-US" sz="1900" dirty="0"/>
+              <a:t>Inventário do Juice Shop</a:t>
+            </a:r>
+            <a:endParaRPr lang="en-US" sz="1850" dirty="0"/>
           </a:p>
           <a:p>
             <a:pPr indent="0" marL="0">
               <a:buNone/>
             </a:pPr>
             <a:r>
-              <a:rPr lang="en-US" sz="1900" b="1" dirty="0">
+              <a:rPr lang="en-US" sz="1850" b="1" dirty="0">
                 <a:solidFill>
                   <a:srgbClr val="12304A"/>
                 </a:solidFill>
               </a:rPr>
               <a:t>Evidência interpretada</a:t>
             </a:r>
-            <a:endParaRPr lang="en-US" sz="1900" dirty="0"/>
+            <a:endParaRPr lang="en-US" sz="1850" dirty="0"/>
           </a:p>
           <a:p>
             <a:pPr indent="0" marL="0">
               <a:buNone/>
             </a:pPr>
             <a:r>
-              <a:rPr lang="en-US" sz="1900" b="1" dirty="0">
+              <a:rPr lang="en-US" sz="1850" b="1" dirty="0">
                 <a:solidFill>
                   <a:srgbClr val="12304A"/>
                 </a:solidFill>
               </a:rPr>
               <a:t>Controle justificado</a:t>
             </a:r>
-            <a:endParaRPr lang="en-US" sz="1900" dirty="0"/>
+            <a:endParaRPr lang="en-US" sz="1850" dirty="0"/>
           </a:p>
           <a:p>
             <a:pPr indent="0" marL="0">
               <a:buNone/>
             </a:pPr>
             <a:r>
-              <a:rPr lang="en-US" sz="1900" b="1" dirty="0">
+              <a:rPr lang="en-US" sz="1850" b="1" dirty="0">
                 <a:solidFill>
                   <a:srgbClr val="12304A"/>
                 </a:solidFill>
               </a:rPr>
               <a:t>Reteste definido</a:t>
             </a:r>
-            <a:endParaRPr lang="en-US" sz="1900" dirty="0"/>
-          </a:p>
-        </p:txBody>
-      </p:sp>
-      <p:sp>
-        <p:nvSpPr>
-          <p:cNvPr id="10" name="Text 8"/>
-          <p:cNvSpPr/>
-          <p:nvPr/>
-        </p:nvSpPr>
-        <p:spPr>
-          <a:xfrm>
-            <a:off x="8321040" y="4800600"/>
-            <a:ext cx="2834640" cy="457200"/>
+            <a:endParaRPr lang="en-US" sz="1850" dirty="0"/>
+          </a:p>
+        </p:txBody>
+      </p:sp>
+      <p:sp>
+        <p:nvSpPr>
+          <p:cNvPr id="12" name="Text 10"/>
+          <p:cNvSpPr/>
+          <p:nvPr/>
+        </p:nvSpPr>
+        <p:spPr>
+          <a:xfrm>
+            <a:off x="8275320" y="4754880"/>
+            <a:ext cx="2926080" cy="457200"/>
           </a:xfrm>
           <a:prstGeom prst="rect">
             <a:avLst/>
@@ -6686,7 +6778,7 @@
       </p:sp>
       <p:sp>
         <p:nvSpPr>
-          <p:cNvPr id="11" name="Shape 9"/>
+          <p:cNvPr id="13" name="Shape 11"/>
           <p:cNvSpPr/>
           <p:nvPr/>
         </p:nvSpPr>
@@ -6709,7 +6801,7 @@
       </p:sp>
       <p:sp>
         <p:nvSpPr>
-          <p:cNvPr id="12" name="Text 10"/>
+          <p:cNvPr id="14" name="Text 12"/>
           <p:cNvSpPr/>
           <p:nvPr/>
         </p:nvSpPr>
@@ -6745,7 +6837,7 @@
       </p:sp>
       <p:sp>
         <p:nvSpPr>
-          <p:cNvPr id="13" name="Text 11"/>
+          <p:cNvPr id="15" name="Text 13"/>
           <p:cNvSpPr/>
           <p:nvPr/>
         </p:nvSpPr>

</xml_diff>